<commit_message>
docs: atualiza apresentação com nova opção de FCK
Agent-Logs-Url: https://github.com/teconcret-star/SOLO_PROPOSTA/sessions/45a76785-b3ac-4bc1-80f5-e710d90f63ef

Co-authored-by: teconcret-star <233576409+teconcret-star@users.noreply.github.com>
</commit_message>
<xml_diff>
--- a/Solomix_Apresentacao.pptx
+++ b/Solomix_Apresentacao.pptx
@@ -4813,7 +4813,7 @@
                   <a:srgbClr val="444444"/>
                 </a:solidFill>
               </a:rPr>
-              <a:t>▶  Tabela de vendas por tipo de concreto (FCK) com volumes e receitas</a:t>
+              <a:t>▶  Tabela de vendas por tipo de concreto (FCK, incluindo 35 MPa) com volumes e receitas</a:t>
             </a:r>
           </a:p>
         </p:txBody>
@@ -10513,7 +10513,7 @@
                   <a:srgbClr val="444444"/>
                 </a:solidFill>
               </a:rPr>
-              <a:t>▶  Itens configuráveis: FCK, volume (m³), brita, slump, preço e margem</a:t>
+              <a:t>▶  Itens configuráveis: FCK (com nova opção 35 MPa), volume (m³), brita, slump, preço e margem</a:t>
             </a:r>
           </a:p>
         </p:txBody>

</xml_diff>